<commit_message>
feat: add thesis text content and update presentation slides for defense
</commit_message>
<xml_diff>
--- a/Thesis Defence Presentation Detailed.pptx
+++ b/Thesis Defence Presentation Detailed.pptx
@@ -505,6 +505,174 @@
     </a:lvl9pPr>
   </p:notesStyle>
 </p:notesMaster>
+</file>
+
+<file path=ppt/notesSlides/notesSlide1.xml><?xml version="1.0" encoding="utf-8"?>
+<p:notes xmlns:a="http://schemas.openxmlformats.org/drawingml/2006/main" xmlns:r="http://schemas.openxmlformats.org/officeDocument/2006/relationships" xmlns:p="http://schemas.openxmlformats.org/presentationml/2006/main">
+  <p:cSld>
+    <p:spTree>
+      <p:nvGrpSpPr>
+        <p:cNvPr id="1" name=""/>
+        <p:cNvGrpSpPr/>
+        <p:nvPr/>
+      </p:nvGrpSpPr>
+      <p:grpSpPr>
+        <a:xfrm>
+          <a:off x="0" y="0"/>
+          <a:ext cx="0" cy="0"/>
+          <a:chOff x="0" y="0"/>
+          <a:chExt cx="0" cy="0"/>
+        </a:xfrm>
+      </p:grpSpPr>
+      <p:sp>
+        <p:nvSpPr>
+          <p:cNvPr id="2" name="Slide Image Placeholder 1"/>
+          <p:cNvSpPr>
+            <a:spLocks noGrp="1" noRot="1" noChangeAspect="1"/>
+          </p:cNvSpPr>
+          <p:nvPr>
+            <p:ph type="sldImg"/>
+          </p:nvPr>
+        </p:nvSpPr>
+        <p:spPr/>
+      </p:sp>
+      <p:sp>
+        <p:nvSpPr>
+          <p:cNvPr id="3" name="Notes Placeholder 2"/>
+          <p:cNvSpPr>
+            <a:spLocks noGrp="1"/>
+          </p:cNvSpPr>
+          <p:nvPr>
+            <p:ph type="body" idx="1"/>
+          </p:nvPr>
+        </p:nvSpPr>
+        <p:spPr/>
+        <p:txBody>
+          <a:bodyPr/>
+          <a:lstStyle/>
+          <a:p>
+            <a:endParaRPr lang="en-US"/>
+          </a:p>
+        </p:txBody>
+      </p:sp>
+      <p:sp>
+        <p:nvSpPr>
+          <p:cNvPr id="4" name="Slide Number Placeholder 3"/>
+          <p:cNvSpPr>
+            <a:spLocks noGrp="1"/>
+          </p:cNvSpPr>
+          <p:nvPr>
+            <p:ph type="sldNum" sz="quarter" idx="5"/>
+          </p:nvPr>
+        </p:nvSpPr>
+        <p:spPr/>
+        <p:txBody>
+          <a:bodyPr/>
+          <a:lstStyle/>
+          <a:p>
+            <a:fld id="{C762F6BD-97DA-5F40-B046-A0BF2F554C1C}" type="slidenum">
+              <a:rPr lang="en-US" smtClean="0"/>
+              <a:t>1</a:t>
+            </a:fld>
+            <a:endParaRPr lang="en-US"/>
+          </a:p>
+        </p:txBody>
+      </p:sp>
+    </p:spTree>
+    <p:extLst>
+      <p:ext uri="{BB962C8B-B14F-4D97-AF65-F5344CB8AC3E}">
+        <p14:creationId xmlns:p14="http://schemas.microsoft.com/office/powerpoint/2010/main" val="2104255067"/>
+      </p:ext>
+    </p:extLst>
+  </p:cSld>
+  <p:clrMapOvr>
+    <a:masterClrMapping/>
+  </p:clrMapOvr>
+</p:notes>
+</file>
+
+<file path=ppt/notesSlides/notesSlide2.xml><?xml version="1.0" encoding="utf-8"?>
+<p:notes xmlns:a="http://schemas.openxmlformats.org/drawingml/2006/main" xmlns:r="http://schemas.openxmlformats.org/officeDocument/2006/relationships" xmlns:p="http://schemas.openxmlformats.org/presentationml/2006/main">
+  <p:cSld>
+    <p:spTree>
+      <p:nvGrpSpPr>
+        <p:cNvPr id="1" name=""/>
+        <p:cNvGrpSpPr/>
+        <p:nvPr/>
+      </p:nvGrpSpPr>
+      <p:grpSpPr>
+        <a:xfrm>
+          <a:off x="0" y="0"/>
+          <a:ext cx="0" cy="0"/>
+          <a:chOff x="0" y="0"/>
+          <a:chExt cx="0" cy="0"/>
+        </a:xfrm>
+      </p:grpSpPr>
+      <p:sp>
+        <p:nvSpPr>
+          <p:cNvPr id="2" name="Slide Image Placeholder 1"/>
+          <p:cNvSpPr>
+            <a:spLocks noGrp="1" noRot="1" noChangeAspect="1"/>
+          </p:cNvSpPr>
+          <p:nvPr>
+            <p:ph type="sldImg"/>
+          </p:nvPr>
+        </p:nvSpPr>
+        <p:spPr/>
+      </p:sp>
+      <p:sp>
+        <p:nvSpPr>
+          <p:cNvPr id="3" name="Notes Placeholder 2"/>
+          <p:cNvSpPr>
+            <a:spLocks noGrp="1"/>
+          </p:cNvSpPr>
+          <p:nvPr>
+            <p:ph type="body" idx="1"/>
+          </p:nvPr>
+        </p:nvSpPr>
+        <p:spPr/>
+        <p:txBody>
+          <a:bodyPr/>
+          <a:lstStyle/>
+          <a:p>
+            <a:endParaRPr lang="en-US"/>
+          </a:p>
+        </p:txBody>
+      </p:sp>
+      <p:sp>
+        <p:nvSpPr>
+          <p:cNvPr id="4" name="Slide Number Placeholder 3"/>
+          <p:cNvSpPr>
+            <a:spLocks noGrp="1"/>
+          </p:cNvSpPr>
+          <p:nvPr>
+            <p:ph type="sldNum" sz="quarter" idx="5"/>
+          </p:nvPr>
+        </p:nvSpPr>
+        <p:spPr/>
+        <p:txBody>
+          <a:bodyPr/>
+          <a:lstStyle/>
+          <a:p>
+            <a:fld id="{C762F6BD-97DA-5F40-B046-A0BF2F554C1C}" type="slidenum">
+              <a:rPr lang="en-US" smtClean="0"/>
+              <a:t>5</a:t>
+            </a:fld>
+            <a:endParaRPr lang="en-US"/>
+          </a:p>
+        </p:txBody>
+      </p:sp>
+    </p:spTree>
+    <p:extLst>
+      <p:ext uri="{BB962C8B-B14F-4D97-AF65-F5344CB8AC3E}">
+        <p14:creationId xmlns:p14="http://schemas.microsoft.com/office/powerpoint/2010/main" val="149921489"/>
+      </p:ext>
+    </p:extLst>
+  </p:cSld>
+  <p:clrMapOvr>
+    <a:masterClrMapping/>
+  </p:clrMapOvr>
+</p:notes>
 </file>
 
 <file path=ppt/slideLayouts/slideLayout1.xml><?xml version="1.0" encoding="utf-8"?>
@@ -3626,7 +3794,7 @@
           <p:nvPr/>
         </p:nvPicPr>
         <p:blipFill>
-          <a:blip r:embed="rId2">
+          <a:blip r:embed="rId3">
             <a:extLst>
               <a:ext uri="{28A0092B-C50C-407E-A947-70E740481C1C}">
                 <a14:useLocalDpi xmlns:a14="http://schemas.microsoft.com/office/drawing/2010/main" val="0"/>

</xml_diff>

<commit_message>
docs: update thesis presentation slides and create comprehensive thesis text document
</commit_message>
<xml_diff>
--- a/Thesis Defence Presentation Detailed.pptx
+++ b/Thesis Defence Presentation Detailed.pptx
@@ -9845,6 +9845,9 @@
               </a:rPr>
               <a:t>6. No director / board-level accountability — fines imposed on entities, not decision-makers.</a:t>
             </a:r>
+            <a:endParaRPr lang="en-IN" sz="1200" dirty="0">
+              <a:latin typeface="Avenir Next" panose="020B0503020202020204" pitchFamily="34" charset="0"/>
+            </a:endParaRPr>
           </a:p>
           <a:p>
             <a:pPr>
@@ -14337,7 +14340,7 @@
                         </a:defRPr>
                       </a:pPr>
                       <a:r>
-                        <a:rPr sz="1600"/>
+                        <a:rPr sz="1600" dirty="0"/>
                         <a:t>European Union</a:t>
                       </a:r>
                     </a:p>
@@ -14469,7 +14472,7 @@
                         </a:defRPr>
                       </a:pPr>
                       <a:r>
-                        <a:rPr sz="1400"/>
+                        <a:rPr sz="1400" dirty="0"/>
                         <a:t>Strong</a:t>
                       </a:r>
                     </a:p>
@@ -14576,7 +14579,7 @@
                         </a:defRPr>
                       </a:pPr>
                       <a:r>
-                        <a:rPr sz="1400"/>
+                        <a:rPr sz="1400" dirty="0"/>
                         <a:t>Integrated architecture</a:t>
                       </a:r>
                     </a:p>
@@ -14840,7 +14843,7 @@
                         </a:defRPr>
                       </a:pPr>
                       <a:r>
-                        <a:rPr sz="1400"/>
+                        <a:rPr sz="1400" dirty="0"/>
                         <a:t>Forward-looking claim controls</a:t>
                       </a:r>
                     </a:p>
@@ -14972,7 +14975,7 @@
                         </a:defRPr>
                       </a:pPr>
                       <a:r>
-                        <a:rPr sz="1400"/>
+                        <a:rPr sz="1400" dirty="0"/>
                         <a:t>Proportionate penalties</a:t>
                       </a:r>
                     </a:p>

</xml_diff>